<commit_message>
Correction from section meeting
</commit_message>
<xml_diff>
--- a/LectureSlides/03b_WhenOneThingDependsOnAother.pptx
+++ b/LectureSlides/03b_WhenOneThingDependsOnAother.pptx
@@ -3842,8 +3842,8 @@
           </a:p>
         </p:txBody>
       </p:sp>
-      <mc:AlternateContent xmlns:mc="http://schemas.openxmlformats.org/markup-compatibility/2006">
-        <mc:Choice xmlns:a14="http://schemas.microsoft.com/office/drawing/2010/main" Requires="a14">
+      <mc:AlternateContent xmlns:mc="http://schemas.openxmlformats.org/markup-compatibility/2006" xmlns:a14="http://schemas.microsoft.com/office/drawing/2010/main">
+        <mc:Choice Requires="a14">
           <p:sp>
             <p:nvSpPr>
               <p:cNvPr id="3" name="Content Placeholder 2"/>
@@ -4098,7 +4098,7 @@
             </p:txBody>
           </p:sp>
         </mc:Choice>
-        <mc:Fallback>
+        <mc:Fallback xmlns="">
           <p:sp>
             <p:nvSpPr>
               <p:cNvPr id="3" name="Content Placeholder 2"/>
@@ -4184,8 +4184,8 @@
           </a:p>
         </p:txBody>
       </p:sp>
-      <mc:AlternateContent xmlns:mc="http://schemas.openxmlformats.org/markup-compatibility/2006">
-        <mc:Choice xmlns:a14="http://schemas.microsoft.com/office/drawing/2010/main" Requires="a14">
+      <mc:AlternateContent xmlns:mc="http://schemas.openxmlformats.org/markup-compatibility/2006" xmlns:a14="http://schemas.microsoft.com/office/drawing/2010/main">
+        <mc:Choice Requires="a14">
           <p:sp>
             <p:nvSpPr>
               <p:cNvPr id="3" name="Content Placeholder 2"/>
@@ -4889,7 +4889,7 @@
             </p:txBody>
           </p:sp>
         </mc:Choice>
-        <mc:Fallback>
+        <mc:Fallback xmlns="">
           <p:sp>
             <p:nvSpPr>
               <p:cNvPr id="3" name="Content Placeholder 2"/>
@@ -5859,7 +5859,7 @@
                 </a:r>
               </a:p>
               <a:p>
-                <a:pPr marL="0" lvl="0" indent="0">
+                <a:pPr marL="0" indent="0">
                   <a:buNone/>
                 </a:pPr>
                 <a14:m>
@@ -5878,7 +5878,7 @@
                         <a:rPr lang="en-US">
                           <a:latin typeface="Cambria Math" panose="02040503050406030204" pitchFamily="18" charset="0"/>
                         </a:rPr>
-                        <m:t>⊥</m:t>
+                        <m:t>∩</m:t>
                       </m:r>
                       <m:r>
                         <a:rPr lang="en-US">
@@ -5902,7 +5902,7 @@
                         <a:rPr lang="en-US">
                           <a:latin typeface="Cambria Math" panose="02040503050406030204" pitchFamily="18" charset="0"/>
                         </a:rPr>
-                        <m:t>⊥</m:t>
+                        <m:t>∩</m:t>
                       </m:r>
                       <m:r>
                         <a:rPr lang="en-US">
@@ -6357,8 +6357,8 @@
           </a:p>
         </p:txBody>
       </p:sp>
-      <mc:AlternateContent xmlns:mc="http://schemas.openxmlformats.org/markup-compatibility/2006">
-        <mc:Choice xmlns:a14="http://schemas.microsoft.com/office/drawing/2010/main" Requires="a14">
+      <mc:AlternateContent xmlns:mc="http://schemas.openxmlformats.org/markup-compatibility/2006" xmlns:a14="http://schemas.microsoft.com/office/drawing/2010/main">
+        <mc:Choice Requires="a14">
           <p:sp>
             <p:nvSpPr>
               <p:cNvPr id="3" name="Content Placeholder 2"/>
@@ -6632,7 +6632,7 @@
             </p:txBody>
           </p:sp>
         </mc:Choice>
-        <mc:Fallback>
+        <mc:Fallback xmlns="">
           <p:sp>
             <p:nvSpPr>
               <p:cNvPr id="3" name="Content Placeholder 2"/>
@@ -9563,7 +9563,7 @@
                       <m:d>
                         <m:dPr>
                           <m:ctrlPr>
-                            <a:rPr lang="en-US" sz="1800" b="0" i="1" smtClean="0">
+                            <a:rPr lang="en-US" sz="1800" i="1">
                               <a:latin typeface="Cambria Math" panose="02040503050406030204" pitchFamily="18" charset="0"/>
                             </a:rPr>
                           </m:ctrlPr>
@@ -9870,7 +9870,7 @@
                       <m:d>
                         <m:dPr>
                           <m:ctrlPr>
-                            <a:rPr lang="en-US" sz="1800" b="0" i="1" smtClean="0">
+                            <a:rPr lang="en-US" sz="1800" i="1">
                               <a:latin typeface="Cambria Math" panose="02040503050406030204" pitchFamily="18" charset="0"/>
                             </a:rPr>
                           </m:ctrlPr>
@@ -11973,8 +11973,8 @@
           </a:p>
         </p:txBody>
       </p:sp>
-      <mc:AlternateContent xmlns:mc="http://schemas.openxmlformats.org/markup-compatibility/2006">
-        <mc:Choice xmlns:a14="http://schemas.microsoft.com/office/drawing/2010/main" Requires="a14">
+      <mc:AlternateContent xmlns:mc="http://schemas.openxmlformats.org/markup-compatibility/2006" xmlns:a14="http://schemas.microsoft.com/office/drawing/2010/main">
+        <mc:Choice Requires="a14">
           <p:sp>
             <p:nvSpPr>
               <p:cNvPr id="3" name="Content Placeholder 2"/>
@@ -12288,7 +12288,7 @@
             </p:txBody>
           </p:sp>
         </mc:Choice>
-        <mc:Fallback>
+        <mc:Fallback xmlns="">
           <p:sp>
             <p:nvSpPr>
               <p:cNvPr id="3" name="Content Placeholder 2"/>
@@ -13378,8 +13378,8 @@
           </a:p>
         </p:txBody>
       </p:sp>
-      <mc:AlternateContent xmlns:mc="http://schemas.openxmlformats.org/markup-compatibility/2006">
-        <mc:Choice xmlns:a14="http://schemas.microsoft.com/office/drawing/2010/main" Requires="a14">
+      <mc:AlternateContent xmlns:mc="http://schemas.openxmlformats.org/markup-compatibility/2006" xmlns:a14="http://schemas.microsoft.com/office/drawing/2010/main">
+        <mc:Choice Requires="a14">
           <p:sp>
             <p:nvSpPr>
               <p:cNvPr id="3" name="Content Placeholder 2"/>
@@ -13568,7 +13568,7 @@
             </p:txBody>
           </p:sp>
         </mc:Choice>
-        <mc:Fallback>
+        <mc:Fallback xmlns="">
           <p:sp>
             <p:nvSpPr>
               <p:cNvPr id="3" name="Content Placeholder 2"/>
@@ -14067,8 +14067,8 @@
           </a:p>
         </p:txBody>
       </p:sp>
-      <mc:AlternateContent xmlns:mc="http://schemas.openxmlformats.org/markup-compatibility/2006">
-        <mc:Choice xmlns:a14="http://schemas.microsoft.com/office/drawing/2010/main" Requires="a14">
+      <mc:AlternateContent xmlns:mc="http://schemas.openxmlformats.org/markup-compatibility/2006" xmlns:a14="http://schemas.microsoft.com/office/drawing/2010/main">
+        <mc:Choice Requires="a14">
           <p:sp>
             <p:nvSpPr>
               <p:cNvPr id="3" name="Content Placeholder 2"/>
@@ -14685,7 +14685,7 @@
             </p:txBody>
           </p:sp>
         </mc:Choice>
-        <mc:Fallback>
+        <mc:Fallback xmlns="">
           <p:sp>
             <p:nvSpPr>
               <p:cNvPr id="3" name="Content Placeholder 2"/>
@@ -15189,8 +15189,8 @@
           </a:p>
         </p:txBody>
       </p:sp>
-      <mc:AlternateContent xmlns:mc="http://schemas.openxmlformats.org/markup-compatibility/2006">
-        <mc:Choice xmlns:a14="http://schemas.microsoft.com/office/drawing/2010/main" Requires="a14">
+      <mc:AlternateContent xmlns:mc="http://schemas.openxmlformats.org/markup-compatibility/2006" xmlns:a14="http://schemas.microsoft.com/office/drawing/2010/main">
+        <mc:Choice Requires="a14">
           <p:sp>
             <p:nvSpPr>
               <p:cNvPr id="3" name="Content Placeholder 2"/>
@@ -15664,7 +15664,7 @@
             </p:txBody>
           </p:sp>
         </mc:Choice>
-        <mc:Fallback>
+        <mc:Fallback xmlns="">
           <p:sp>
             <p:nvSpPr>
               <p:cNvPr id="3" name="Content Placeholder 2"/>
@@ -16805,8 +16805,9 @@
                       <m:func>
                         <m:funcPr>
                           <m:ctrlPr>
-                            <a:rPr lang="en-US" b="0" i="1" smtClean="0">
-                              <a:latin typeface="Cambria Math" panose="02040503050406030204" pitchFamily="18" charset="0"/>
+                            <a:rPr lang="en-US" i="1" smtClean="0">
+                              <a:latin typeface="Cambria Math" panose="02040503050406030204" pitchFamily="18" charset="0"/>
+                              <a:ea typeface="Cambria Math" panose="02040503050406030204" pitchFamily="18" charset="0"/>
                             </a:rPr>
                           </m:ctrlPr>
                         </m:funcPr>
@@ -17464,8 +17465,8 @@
           </a:p>
         </p:txBody>
       </p:sp>
-      <mc:AlternateContent xmlns:mc="http://schemas.openxmlformats.org/markup-compatibility/2006">
-        <mc:Choice xmlns:a14="http://schemas.microsoft.com/office/drawing/2010/main" Requires="a14">
+      <mc:AlternateContent xmlns:mc="http://schemas.openxmlformats.org/markup-compatibility/2006" xmlns:a14="http://schemas.microsoft.com/office/drawing/2010/main">
+        <mc:Choice Requires="a14">
           <p:sp>
             <p:nvSpPr>
               <p:cNvPr id="3" name="Content Placeholder 2"/>
@@ -18346,7 +18347,7 @@
             </p:txBody>
           </p:sp>
         </mc:Choice>
-        <mc:Fallback>
+        <mc:Fallback xmlns="">
           <p:sp>
             <p:nvSpPr>
               <p:cNvPr id="3" name="Content Placeholder 2"/>
@@ -24743,8 +24744,8 @@
           </a:p>
         </p:txBody>
       </p:sp>
-      <mc:AlternateContent xmlns:mc="http://schemas.openxmlformats.org/markup-compatibility/2006">
-        <mc:Choice xmlns:a14="http://schemas.microsoft.com/office/drawing/2010/main" Requires="a14">
+      <mc:AlternateContent xmlns:mc="http://schemas.openxmlformats.org/markup-compatibility/2006" xmlns:a14="http://schemas.microsoft.com/office/drawing/2010/main">
+        <mc:Choice Requires="a14">
           <p:sp>
             <p:nvSpPr>
               <p:cNvPr id="3" name="Content Placeholder 2"/>
@@ -25493,7 +25494,7 @@
             </p:txBody>
           </p:sp>
         </mc:Choice>
-        <mc:Fallback>
+        <mc:Fallback xmlns="">
           <p:sp>
             <p:nvSpPr>
               <p:cNvPr id="3" name="Content Placeholder 2"/>

</xml_diff>